<commit_message>
fix(prezentatsiya): v8 — rasmlar ko‘rinishi (PNG alpha olib tashlandi)
PowerPoint/mobil ba’zan shaffof PNG overlay ni qora qilib yopardi.
Endi rasmlar pishirilgan JPG + matn qattiq panelda. Brauzer uchun korish.html.

Co-authored-by: Dilshod Zokirov <DilshodZokirov@users.noreply.github.com>
</commit_message>
<xml_diff>
--- a/python-prezentatsiya/Python-Django-PBL-v5.pptx
+++ b/python-prezentatsiya/Python-Django-PBL-v5.pptx
@@ -3113,7 +3113,7 @@
       <p:grpSpPr/>
       <p:pic>
         <p:nvPicPr>
-          <p:cNvPr id="2" name="Picture 1" descr="hero-youth-coding.jpg"/>
+          <p:cNvPr id="2" name="Picture 1" descr="hero-baked.jpg"/>
           <p:cNvPicPr>
             <a:picLocks noChangeAspect="1"/>
           </p:cNvPicPr>
@@ -3135,33 +3135,9 @@
           </a:prstGeom>
         </p:spPr>
       </p:pic>
-      <p:pic>
-        <p:nvPicPr>
-          <p:cNvPr id="3" name="Picture 2" descr="overlay-dark.png"/>
-          <p:cNvPicPr>
-            <a:picLocks noChangeAspect="1"/>
-          </p:cNvPicPr>
-          <p:nvPr/>
-        </p:nvPicPr>
-        <p:blipFill>
-          <a:blip r:embed="rId3"/>
-          <a:stretch>
-            <a:fillRect/>
-          </a:stretch>
-        </p:blipFill>
-        <p:spPr>
-          <a:xfrm>
-            <a:off x="0" y="0"/>
-            <a:ext cx="12191695" cy="6858000"/>
-          </a:xfrm>
-          <a:prstGeom prst="rect">
-            <a:avLst/>
-          </a:prstGeom>
-        </p:spPr>
-      </p:pic>
-      <p:sp>
-        <p:nvSpPr>
-          <p:cNvPr id="4" name="Rectangle 3"/>
+      <p:sp>
+        <p:nvSpPr>
+          <p:cNvPr id="3" name="Rectangle 2"/>
           <p:cNvSpPr/>
           <p:nvPr/>
         </p:nvSpPr>
@@ -3204,20 +3180,20 @@
       </p:sp>
       <p:sp>
         <p:nvSpPr>
-          <p:cNvPr id="5" name="Rounded Rectangle 4"/>
+          <p:cNvPr id="4" name="Rounded Rectangle 3"/>
           <p:cNvSpPr/>
           <p:nvPr/>
         </p:nvSpPr>
         <p:spPr>
           <a:xfrm>
-            <a:off x="640080" y="1234440"/>
-            <a:ext cx="4206240" cy="365760"/>
+            <a:off x="411480" y="1005840"/>
+            <a:ext cx="8412480" cy="4846320"/>
           </a:xfrm>
           <a:prstGeom prst="roundRect">
             <a:avLst/>
           </a:prstGeom>
           <a:solidFill>
-            <a:srgbClr val="0284C7"/>
+            <a:srgbClr val="0B1220"/>
           </a:solidFill>
           <a:ln>
             <a:noFill/>
@@ -3247,14 +3223,57 @@
       </p:sp>
       <p:sp>
         <p:nvSpPr>
+          <p:cNvPr id="5" name="Rounded Rectangle 4"/>
+          <p:cNvSpPr/>
+          <p:nvPr/>
+        </p:nvSpPr>
+        <p:spPr>
+          <a:xfrm>
+            <a:off x="685800" y="1280160"/>
+            <a:ext cx="4389120" cy="365760"/>
+          </a:xfrm>
+          <a:prstGeom prst="roundRect">
+            <a:avLst/>
+          </a:prstGeom>
+          <a:solidFill>
+            <a:srgbClr val="0284C7"/>
+          </a:solidFill>
+          <a:ln>
+            <a:noFill/>
+          </a:ln>
+        </p:spPr>
+        <p:style>
+          <a:lnRef idx="1">
+            <a:schemeClr val="accent1"/>
+          </a:lnRef>
+          <a:fillRef idx="3">
+            <a:schemeClr val="accent1"/>
+          </a:fillRef>
+          <a:effectRef idx="2">
+            <a:schemeClr val="accent1"/>
+          </a:effectRef>
+          <a:fontRef idx="minor">
+            <a:schemeClr val="lt1"/>
+          </a:fontRef>
+        </p:style>
+        <p:txBody>
+          <a:bodyPr rtlCol="0" anchor="ctr"/>
+          <a:lstStyle/>
+          <a:p>
+            <a:pPr algn="ctr"/>
+          </a:p>
+        </p:txBody>
+      </p:sp>
+      <p:sp>
+        <p:nvSpPr>
           <p:cNvPr id="6" name="TextBox 5"/>
           <p:cNvSpPr txBox="1"/>
           <p:nvPr/>
         </p:nvSpPr>
         <p:spPr>
           <a:xfrm>
-            <a:off x="640080" y="1234440"/>
-            <a:ext cx="4206240" cy="365760"/>
+            <a:off x="685800" y="1280160"/>
+            <a:ext cx="4389120" cy="365760"/>
           </a:xfrm>
           <a:prstGeom prst="rect">
             <a:avLst/>
@@ -3294,8 +3313,8 @@
         </p:nvSpPr>
         <p:spPr>
           <a:xfrm>
-            <a:off x="640080" y="1828800"/>
-            <a:ext cx="8686800" cy="3840480"/>
+            <a:off x="685800" y="1874519"/>
+            <a:ext cx="7863840" cy="3474720"/>
           </a:xfrm>
           <a:prstGeom prst="rect">
             <a:avLst/>
@@ -3314,7 +3333,7 @@
               </a:spcAft>
             </a:pPr>
             <a:r>
-              <a:rPr sz="3400" b="1">
+              <a:rPr sz="3200" b="1">
                 <a:solidFill>
                   <a:srgbClr val="FFFFFF"/>
                 </a:solidFill>
@@ -3328,11 +3347,11 @@
           <a:p>
             <a:pPr algn="l">
               <a:spcAft>
-                <a:spcPts val="1600"/>
-              </a:spcAft>
-            </a:pPr>
-            <a:r>
-              <a:rPr sz="1700" b="0">
+                <a:spcPts val="1400"/>
+              </a:spcAft>
+            </a:pPr>
+            <a:r>
+              <a:rPr sz="1600" b="0">
                 <a:solidFill>
                   <a:srgbClr val="E2E8F0"/>
                 </a:solidFill>
@@ -3352,7 +3371,7 @@
               </a:spcAft>
             </a:pPr>
             <a:r>
-              <a:rPr sz="1800" b="1">
+              <a:rPr sz="1700" b="1">
                 <a:solidFill>
                   <a:srgbClr val="FDBA74"/>
                 </a:solidFill>
@@ -3373,8 +3392,8 @@
         </p:nvSpPr>
         <p:spPr>
           <a:xfrm>
-            <a:off x="640080" y="6126480"/>
-            <a:ext cx="9144000" cy="365760"/>
+            <a:off x="685800" y="5349240"/>
+            <a:ext cx="7863840" cy="320040"/>
           </a:xfrm>
           <a:prstGeom prst="rect">
             <a:avLst/>
@@ -3395,13 +3414,13 @@
             <a:r>
               <a:rPr sz="1200" b="0">
                 <a:solidFill>
-                  <a:srgbClr val="CBD5E1"/>
+                  <a:srgbClr val="94A3B8"/>
                 </a:solidFill>
                 <a:latin typeface="Calibri"/>
                 <a:ea typeface="Calibri"/>
                 <a:cs typeface="Calibri"/>
               </a:rPr>
-              <a:t>v7 · rasmlar + o‘zbekcha atamalar (inglizchasi qavsda)</a:t>
+              <a:t>v8 · rasmlar aniq ko‘rinadi · o‘zbekcha atamalar (inglizchasi qavsda)</a:t>
             </a:r>
           </a:p>
         </p:txBody>
@@ -6136,7 +6155,7 @@
       </p:sp>
       <p:pic>
         <p:nvPicPr>
-          <p:cNvPr id="6" name="Picture 5" descr="multi-platform.jpg"/>
+          <p:cNvPr id="6" name="Picture 5" descr="panel-multi.jpg"/>
           <p:cNvPicPr>
             <a:picLocks noChangeAspect="1"/>
           </p:cNvPicPr>
@@ -6158,33 +6177,9 @@
           </a:prstGeom>
         </p:spPr>
       </p:pic>
-      <p:pic>
-        <p:nvPicPr>
-          <p:cNvPr id="7" name="Picture 6" descr="overlay-soft.png"/>
-          <p:cNvPicPr>
-            <a:picLocks noChangeAspect="1"/>
-          </p:cNvPicPr>
-          <p:nvPr/>
-        </p:nvPicPr>
-        <p:blipFill>
-          <a:blip r:embed="rId3"/>
-          <a:stretch>
-            <a:fillRect/>
-          </a:stretch>
-        </p:blipFill>
-        <p:spPr>
-          <a:xfrm>
-            <a:off x="7635240" y="0"/>
-            <a:ext cx="4572000" cy="6858000"/>
-          </a:xfrm>
-          <a:prstGeom prst="rect">
-            <a:avLst/>
-          </a:prstGeom>
-        </p:spPr>
-      </p:pic>
-      <p:sp>
-        <p:nvSpPr>
-          <p:cNvPr id="8" name="TextBox 7"/>
+      <p:sp>
+        <p:nvSpPr>
+          <p:cNvPr id="7" name="TextBox 6"/>
           <p:cNvSpPr txBox="1"/>
           <p:nvPr/>
         </p:nvSpPr>
@@ -6243,7 +6238,7 @@
       </p:sp>
       <p:sp>
         <p:nvSpPr>
-          <p:cNvPr id="9" name="Rounded Rectangle 8"/>
+          <p:cNvPr id="8" name="Rounded Rectangle 7"/>
           <p:cNvSpPr/>
           <p:nvPr/>
         </p:nvSpPr>
@@ -6288,7 +6283,7 @@
       </p:sp>
       <p:sp>
         <p:nvSpPr>
-          <p:cNvPr id="10" name="TextBox 9"/>
+          <p:cNvPr id="9" name="TextBox 8"/>
           <p:cNvSpPr txBox="1"/>
           <p:nvPr/>
         </p:nvSpPr>
@@ -7946,7 +7941,7 @@
       <p:grpSpPr/>
       <p:pic>
         <p:nvPicPr>
-          <p:cNvPr id="2" name="Picture 1" descr="conclusion-path.jpg"/>
+          <p:cNvPr id="2" name="Picture 1" descr="conclusion-baked.jpg"/>
           <p:cNvPicPr>
             <a:picLocks noChangeAspect="1"/>
           </p:cNvPicPr>
@@ -7968,33 +7963,9 @@
           </a:prstGeom>
         </p:spPr>
       </p:pic>
-      <p:pic>
-        <p:nvPicPr>
-          <p:cNvPr id="3" name="Picture 2" descr="overlay-dark.png"/>
-          <p:cNvPicPr>
-            <a:picLocks noChangeAspect="1"/>
-          </p:cNvPicPr>
-          <p:nvPr/>
-        </p:nvPicPr>
-        <p:blipFill>
-          <a:blip r:embed="rId3"/>
-          <a:stretch>
-            <a:fillRect/>
-          </a:stretch>
-        </p:blipFill>
-        <p:spPr>
-          <a:xfrm>
-            <a:off x="0" y="0"/>
-            <a:ext cx="12191695" cy="6858000"/>
-          </a:xfrm>
-          <a:prstGeom prst="rect">
-            <a:avLst/>
-          </a:prstGeom>
-        </p:spPr>
-      </p:pic>
-      <p:sp>
-        <p:nvSpPr>
-          <p:cNvPr id="4" name="Rectangle 3"/>
+      <p:sp>
+        <p:nvSpPr>
+          <p:cNvPr id="3" name="Rectangle 2"/>
           <p:cNvSpPr/>
           <p:nvPr/>
         </p:nvSpPr>
@@ -8037,20 +8008,20 @@
       </p:sp>
       <p:sp>
         <p:nvSpPr>
-          <p:cNvPr id="5" name="Rounded Rectangle 4"/>
+          <p:cNvPr id="4" name="Rounded Rectangle 3"/>
           <p:cNvSpPr/>
           <p:nvPr/>
         </p:nvSpPr>
         <p:spPr>
           <a:xfrm>
-            <a:off x="640080" y="640080"/>
-            <a:ext cx="2011680" cy="347472"/>
+            <a:off x="365760" y="411480"/>
+            <a:ext cx="11430000" cy="6035040"/>
           </a:xfrm>
           <a:prstGeom prst="roundRect">
             <a:avLst/>
           </a:prstGeom>
           <a:solidFill>
-            <a:srgbClr val="047857"/>
+            <a:srgbClr val="0B1220"/>
           </a:solidFill>
           <a:ln>
             <a:noFill/>
@@ -8080,8 +8051,8 @@
       </p:sp>
       <p:sp>
         <p:nvSpPr>
-          <p:cNvPr id="6" name="TextBox 5"/>
-          <p:cNvSpPr txBox="1"/>
+          <p:cNvPr id="5" name="Rounded Rectangle 4"/>
+          <p:cNvSpPr/>
           <p:nvPr/>
         </p:nvSpPr>
         <p:spPr>
@@ -8089,93 +8060,11 @@
             <a:off x="640080" y="640080"/>
             <a:ext cx="2011680" cy="347472"/>
           </a:xfrm>
-          <a:prstGeom prst="rect">
-            <a:avLst/>
-          </a:prstGeom>
-          <a:noFill/>
-        </p:spPr>
-        <p:txBody>
-          <a:bodyPr wrap="square" anchor="ctr">
-            <a:spAutoFit/>
-          </a:bodyPr>
-          <a:lstStyle/>
-          <a:p>
-            <a:pPr algn="ctr">
-              <a:spcAft>
-                <a:spcPts val="0"/>
-              </a:spcAft>
-            </a:pPr>
-            <a:r>
-              <a:rPr sz="1100" b="1">
-                <a:solidFill>
-                  <a:srgbClr val="FFFFFF"/>
-                </a:solidFill>
-                <a:latin typeface="Calibri"/>
-                <a:ea typeface="Calibri"/>
-                <a:cs typeface="Calibri"/>
-              </a:rPr>
-              <a:t>XULOSA</a:t>
-            </a:r>
-          </a:p>
-        </p:txBody>
-      </p:sp>
-      <p:sp>
-        <p:nvSpPr>
-          <p:cNvPr id="7" name="TextBox 6"/>
-          <p:cNvSpPr txBox="1"/>
-          <p:nvPr/>
-        </p:nvSpPr>
-        <p:spPr>
-          <a:xfrm>
-            <a:off x="640080" y="1188720"/>
-            <a:ext cx="10789920" cy="640080"/>
-          </a:xfrm>
-          <a:prstGeom prst="rect">
-            <a:avLst/>
-          </a:prstGeom>
-          <a:noFill/>
-        </p:spPr>
-        <p:txBody>
-          <a:bodyPr wrap="square" anchor="t">
-            <a:spAutoFit/>
-          </a:bodyPr>
-          <a:lstStyle/>
-          <a:p>
-            <a:pPr algn="l">
-              <a:spcAft>
-                <a:spcPts val="0"/>
-              </a:spcAft>
-            </a:pPr>
-            <a:r>
-              <a:rPr sz="2600" b="1">
-                <a:solidFill>
-                  <a:srgbClr val="FFFFFF"/>
-                </a:solidFill>
-                <a:latin typeface="Calibri"/>
-                <a:ea typeface="Calibri"/>
-                <a:cs typeface="Calibri"/>
-              </a:rPr>
-              <a:t>Bugungi darsdan olib ketiladigan asoslar</a:t>
-            </a:r>
-          </a:p>
-        </p:txBody>
-      </p:sp>
-      <p:sp>
-        <p:nvSpPr>
-          <p:cNvPr id="8" name="Oval 7"/>
-          <p:cNvSpPr/>
-          <p:nvPr/>
-        </p:nvSpPr>
-        <p:spPr>
-          <a:xfrm>
-            <a:off x="685800" y="2103120"/>
-            <a:ext cx="502920" cy="502920"/>
-          </a:xfrm>
-          <a:prstGeom prst="ellipse">
-            <a:avLst/>
-          </a:prstGeom>
-          <a:solidFill>
-            <a:srgbClr val="0284C7"/>
+          <a:prstGeom prst="roundRect">
+            <a:avLst/>
+          </a:prstGeom>
+          <a:solidFill>
+            <a:srgbClr val="047857"/>
           </a:solidFill>
           <a:ln>
             <a:noFill/>
@@ -8205,14 +8094,55 @@
       </p:sp>
       <p:sp>
         <p:nvSpPr>
-          <p:cNvPr id="9" name="TextBox 8"/>
+          <p:cNvPr id="6" name="TextBox 5"/>
           <p:cNvSpPr txBox="1"/>
           <p:nvPr/>
         </p:nvSpPr>
         <p:spPr>
           <a:xfrm>
-            <a:off x="685800" y="2167128"/>
-            <a:ext cx="502920" cy="365760"/>
+            <a:off x="640080" y="640080"/>
+            <a:ext cx="2011680" cy="347472"/>
+          </a:xfrm>
+          <a:prstGeom prst="rect">
+            <a:avLst/>
+          </a:prstGeom>
+          <a:noFill/>
+        </p:spPr>
+        <p:txBody>
+          <a:bodyPr wrap="square" anchor="ctr">
+            <a:spAutoFit/>
+          </a:bodyPr>
+          <a:lstStyle/>
+          <a:p>
+            <a:pPr algn="ctr">
+              <a:spcAft>
+                <a:spcPts val="0"/>
+              </a:spcAft>
+            </a:pPr>
+            <a:r>
+              <a:rPr sz="1100" b="1">
+                <a:solidFill>
+                  <a:srgbClr val="FFFFFF"/>
+                </a:solidFill>
+                <a:latin typeface="Calibri"/>
+                <a:ea typeface="Calibri"/>
+                <a:cs typeface="Calibri"/>
+              </a:rPr>
+              <a:t>XULOSA</a:t>
+            </a:r>
+          </a:p>
+        </p:txBody>
+      </p:sp>
+      <p:sp>
+        <p:nvSpPr>
+          <p:cNvPr id="7" name="TextBox 6"/>
+          <p:cNvSpPr txBox="1"/>
+          <p:nvPr/>
+        </p:nvSpPr>
+        <p:spPr>
+          <a:xfrm>
+            <a:off x="640080" y="1143000"/>
+            <a:ext cx="10789920" cy="548640"/>
           </a:xfrm>
           <a:prstGeom prst="rect">
             <a:avLst/>
@@ -8225,13 +8155,13 @@
           </a:bodyPr>
           <a:lstStyle/>
           <a:p>
-            <a:pPr algn="ctr">
+            <a:pPr algn="l">
               <a:spcAft>
                 <a:spcPts val="0"/>
               </a:spcAft>
             </a:pPr>
             <a:r>
-              <a:rPr sz="1400" b="1">
+              <a:rPr sz="2400" b="1">
                 <a:solidFill>
                   <a:srgbClr val="FFFFFF"/>
                 </a:solidFill>
@@ -8239,6 +8169,90 @@
                 <a:ea typeface="Calibri"/>
                 <a:cs typeface="Calibri"/>
               </a:rPr>
+              <a:t>Bugungi darsdan olib ketiladigan asoslar</a:t>
+            </a:r>
+          </a:p>
+        </p:txBody>
+      </p:sp>
+      <p:sp>
+        <p:nvSpPr>
+          <p:cNvPr id="8" name="Oval 7"/>
+          <p:cNvSpPr/>
+          <p:nvPr/>
+        </p:nvSpPr>
+        <p:spPr>
+          <a:xfrm>
+            <a:off x="685800" y="2011679"/>
+            <a:ext cx="502920" cy="502920"/>
+          </a:xfrm>
+          <a:prstGeom prst="ellipse">
+            <a:avLst/>
+          </a:prstGeom>
+          <a:solidFill>
+            <a:srgbClr val="0284C7"/>
+          </a:solidFill>
+          <a:ln>
+            <a:noFill/>
+          </a:ln>
+        </p:spPr>
+        <p:style>
+          <a:lnRef idx="1">
+            <a:schemeClr val="accent1"/>
+          </a:lnRef>
+          <a:fillRef idx="3">
+            <a:schemeClr val="accent1"/>
+          </a:fillRef>
+          <a:effectRef idx="2">
+            <a:schemeClr val="accent1"/>
+          </a:effectRef>
+          <a:fontRef idx="minor">
+            <a:schemeClr val="lt1"/>
+          </a:fontRef>
+        </p:style>
+        <p:txBody>
+          <a:bodyPr rtlCol="0" anchor="ctr"/>
+          <a:lstStyle/>
+          <a:p>
+            <a:pPr algn="ctr"/>
+          </a:p>
+        </p:txBody>
+      </p:sp>
+      <p:sp>
+        <p:nvSpPr>
+          <p:cNvPr id="9" name="TextBox 8"/>
+          <p:cNvSpPr txBox="1"/>
+          <p:nvPr/>
+        </p:nvSpPr>
+        <p:spPr>
+          <a:xfrm>
+            <a:off x="685800" y="2075687"/>
+            <a:ext cx="502920" cy="365760"/>
+          </a:xfrm>
+          <a:prstGeom prst="rect">
+            <a:avLst/>
+          </a:prstGeom>
+          <a:noFill/>
+        </p:spPr>
+        <p:txBody>
+          <a:bodyPr wrap="square" anchor="t">
+            <a:spAutoFit/>
+          </a:bodyPr>
+          <a:lstStyle/>
+          <a:p>
+            <a:pPr algn="ctr">
+              <a:spcAft>
+                <a:spcPts val="0"/>
+              </a:spcAft>
+            </a:pPr>
+            <a:r>
+              <a:rPr sz="1400" b="1">
+                <a:solidFill>
+                  <a:srgbClr val="FFFFFF"/>
+                </a:solidFill>
+                <a:latin typeface="Calibri"/>
+                <a:ea typeface="Calibri"/>
+                <a:cs typeface="Calibri"/>
+              </a:rPr>
               <a:t>1</a:t>
             </a:r>
           </a:p>
@@ -8252,14 +8266,14 @@
         </p:nvSpPr>
         <p:spPr>
           <a:xfrm>
-            <a:off x="1417320" y="1965960"/>
+            <a:off x="1417320" y="1874519"/>
             <a:ext cx="9875520" cy="914400"/>
           </a:xfrm>
           <a:prstGeom prst="roundRect">
             <a:avLst/>
           </a:prstGeom>
           <a:solidFill>
-            <a:srgbClr val="0F172A"/>
+            <a:srgbClr val="15233B"/>
           </a:solidFill>
           <a:ln w="15875">
             <a:solidFill>
@@ -8297,7 +8311,7 @@
         </p:nvSpPr>
         <p:spPr>
           <a:xfrm>
-            <a:off x="1691640" y="2103120"/>
+            <a:off x="1691640" y="2011679"/>
             <a:ext cx="9418320" cy="685800"/>
           </a:xfrm>
           <a:prstGeom prst="rect">
@@ -8356,7 +8370,7 @@
         </p:nvSpPr>
         <p:spPr>
           <a:xfrm>
-            <a:off x="685800" y="3154680"/>
+            <a:off x="685800" y="3063239"/>
             <a:ext cx="502920" cy="502920"/>
           </a:xfrm>
           <a:prstGeom prst="ellipse">
@@ -8399,7 +8413,7 @@
         </p:nvSpPr>
         <p:spPr>
           <a:xfrm>
-            <a:off x="685800" y="3218688"/>
+            <a:off x="685800" y="3127247"/>
             <a:ext cx="502920" cy="365760"/>
           </a:xfrm>
           <a:prstGeom prst="rect">
@@ -8440,14 +8454,14 @@
         </p:nvSpPr>
         <p:spPr>
           <a:xfrm>
-            <a:off x="1417320" y="3017520"/>
+            <a:off x="1417320" y="2926079"/>
             <a:ext cx="9875520" cy="914400"/>
           </a:xfrm>
           <a:prstGeom prst="roundRect">
             <a:avLst/>
           </a:prstGeom>
           <a:solidFill>
-            <a:srgbClr val="0F172A"/>
+            <a:srgbClr val="15233B"/>
           </a:solidFill>
           <a:ln w="15875">
             <a:solidFill>
@@ -8485,7 +8499,7 @@
         </p:nvSpPr>
         <p:spPr>
           <a:xfrm>
-            <a:off x="1691640" y="3154680"/>
+            <a:off x="1691640" y="3063239"/>
             <a:ext cx="9418320" cy="685800"/>
           </a:xfrm>
           <a:prstGeom prst="rect">
@@ -8544,7 +8558,7 @@
         </p:nvSpPr>
         <p:spPr>
           <a:xfrm>
-            <a:off x="685800" y="4206240"/>
+            <a:off x="685800" y="4114799"/>
             <a:ext cx="502920" cy="502920"/>
           </a:xfrm>
           <a:prstGeom prst="ellipse">
@@ -8587,7 +8601,7 @@
         </p:nvSpPr>
         <p:spPr>
           <a:xfrm>
-            <a:off x="685800" y="4270248"/>
+            <a:off x="685800" y="4178807"/>
             <a:ext cx="502920" cy="365760"/>
           </a:xfrm>
           <a:prstGeom prst="rect">
@@ -8628,14 +8642,14 @@
         </p:nvSpPr>
         <p:spPr>
           <a:xfrm>
-            <a:off x="1417320" y="4069080"/>
+            <a:off x="1417320" y="3977639"/>
             <a:ext cx="9875520" cy="914400"/>
           </a:xfrm>
           <a:prstGeom prst="roundRect">
             <a:avLst/>
           </a:prstGeom>
           <a:solidFill>
-            <a:srgbClr val="0F172A"/>
+            <a:srgbClr val="15233B"/>
           </a:solidFill>
           <a:ln w="15875">
             <a:solidFill>
@@ -8673,7 +8687,7 @@
         </p:nvSpPr>
         <p:spPr>
           <a:xfrm>
-            <a:off x="1691640" y="4206240"/>
+            <a:off x="1691640" y="4114799"/>
             <a:ext cx="9418320" cy="685800"/>
           </a:xfrm>
           <a:prstGeom prst="rect">
@@ -8732,7 +8746,7 @@
         </p:nvSpPr>
         <p:spPr>
           <a:xfrm>
-            <a:off x="685800" y="5257799"/>
+            <a:off x="685800" y="5166358"/>
             <a:ext cx="502920" cy="502920"/>
           </a:xfrm>
           <a:prstGeom prst="ellipse">
@@ -8775,7 +8789,7 @@
         </p:nvSpPr>
         <p:spPr>
           <a:xfrm>
-            <a:off x="685800" y="5321807"/>
+            <a:off x="685800" y="5230366"/>
             <a:ext cx="502920" cy="365760"/>
           </a:xfrm>
           <a:prstGeom prst="rect">
@@ -8816,14 +8830,14 @@
         </p:nvSpPr>
         <p:spPr>
           <a:xfrm>
-            <a:off x="1417320" y="5120639"/>
+            <a:off x="1417320" y="5029198"/>
             <a:ext cx="9875520" cy="914400"/>
           </a:xfrm>
           <a:prstGeom prst="roundRect">
             <a:avLst/>
           </a:prstGeom>
           <a:solidFill>
-            <a:srgbClr val="0F172A"/>
+            <a:srgbClr val="15233B"/>
           </a:solidFill>
           <a:ln w="15875">
             <a:solidFill>
@@ -8861,7 +8875,7 @@
         </p:nvSpPr>
         <p:spPr>
           <a:xfrm>
-            <a:off x="1691640" y="5257799"/>
+            <a:off x="1691640" y="5166358"/>
             <a:ext cx="9418320" cy="685800"/>
           </a:xfrm>
           <a:prstGeom prst="rect">
@@ -9112,7 +9126,7 @@
       </p:sp>
       <p:pic>
         <p:nvPicPr>
-          <p:cNvPr id="6" name="Picture 5" descr="python-concept.jpg"/>
+          <p:cNvPr id="6" name="Picture 5" descr="panel-python.jpg"/>
           <p:cNvPicPr>
             <a:picLocks noChangeAspect="1"/>
           </p:cNvPicPr>
@@ -9134,33 +9148,9 @@
           </a:prstGeom>
         </p:spPr>
       </p:pic>
-      <p:pic>
-        <p:nvPicPr>
-          <p:cNvPr id="7" name="Picture 6" descr="overlay-soft.png"/>
-          <p:cNvPicPr>
-            <a:picLocks noChangeAspect="1"/>
-          </p:cNvPicPr>
-          <p:nvPr/>
-        </p:nvPicPr>
-        <p:blipFill>
-          <a:blip r:embed="rId3"/>
-          <a:stretch>
-            <a:fillRect/>
-          </a:stretch>
-        </p:blipFill>
-        <p:spPr>
-          <a:xfrm>
-            <a:off x="7635240" y="0"/>
-            <a:ext cx="4572000" cy="6858000"/>
-          </a:xfrm>
-          <a:prstGeom prst="rect">
-            <a:avLst/>
-          </a:prstGeom>
-        </p:spPr>
-      </p:pic>
-      <p:sp>
-        <p:nvSpPr>
-          <p:cNvPr id="8" name="TextBox 7"/>
+      <p:sp>
+        <p:nvSpPr>
+          <p:cNvPr id="7" name="TextBox 6"/>
           <p:cNvSpPr txBox="1"/>
           <p:nvPr/>
         </p:nvSpPr>
@@ -9219,7 +9209,7 @@
       </p:sp>
       <p:sp>
         <p:nvSpPr>
-          <p:cNvPr id="9" name="Rounded Rectangle 8"/>
+          <p:cNvPr id="8" name="Rounded Rectangle 7"/>
           <p:cNvSpPr/>
           <p:nvPr/>
         </p:nvSpPr>
@@ -9264,7 +9254,7 @@
       </p:sp>
       <p:sp>
         <p:nvSpPr>
-          <p:cNvPr id="10" name="TextBox 9"/>
+          <p:cNvPr id="9" name="TextBox 8"/>
           <p:cNvSpPr txBox="1"/>
           <p:nvPr/>
         </p:nvSpPr>
@@ -9306,7 +9296,7 @@
       </p:sp>
       <p:sp>
         <p:nvSpPr>
-          <p:cNvPr id="11" name="Rounded Rectangle 10"/>
+          <p:cNvPr id="10" name="Rounded Rectangle 9"/>
           <p:cNvSpPr/>
           <p:nvPr/>
         </p:nvSpPr>
@@ -9351,7 +9341,7 @@
       </p:sp>
       <p:sp>
         <p:nvSpPr>
-          <p:cNvPr id="12" name="Rectangle 11"/>
+          <p:cNvPr id="11" name="Rectangle 10"/>
           <p:cNvSpPr/>
           <p:nvPr/>
         </p:nvSpPr>
@@ -9394,7 +9384,7 @@
       </p:sp>
       <p:sp>
         <p:nvSpPr>
-          <p:cNvPr id="13" name="TextBox 12"/>
+          <p:cNvPr id="12" name="TextBox 11"/>
           <p:cNvSpPr txBox="1"/>
           <p:nvPr/>
         </p:nvSpPr>
@@ -9453,7 +9443,7 @@
       </p:sp>
       <p:sp>
         <p:nvSpPr>
-          <p:cNvPr id="14" name="Rounded Rectangle 13"/>
+          <p:cNvPr id="13" name="Rounded Rectangle 12"/>
           <p:cNvSpPr/>
           <p:nvPr/>
         </p:nvSpPr>
@@ -9498,7 +9488,7 @@
       </p:sp>
       <p:sp>
         <p:nvSpPr>
-          <p:cNvPr id="15" name="Rectangle 14"/>
+          <p:cNvPr id="14" name="Rectangle 13"/>
           <p:cNvSpPr/>
           <p:nvPr/>
         </p:nvSpPr>
@@ -9541,7 +9531,7 @@
       </p:sp>
       <p:sp>
         <p:nvSpPr>
-          <p:cNvPr id="16" name="TextBox 15"/>
+          <p:cNvPr id="15" name="TextBox 14"/>
           <p:cNvSpPr txBox="1"/>
           <p:nvPr/>
         </p:nvSpPr>
@@ -9600,7 +9590,7 @@
       </p:sp>
       <p:sp>
         <p:nvSpPr>
-          <p:cNvPr id="17" name="Rounded Rectangle 16"/>
+          <p:cNvPr id="16" name="Rounded Rectangle 15"/>
           <p:cNvSpPr/>
           <p:nvPr/>
         </p:nvSpPr>
@@ -9645,7 +9635,7 @@
       </p:sp>
       <p:sp>
         <p:nvSpPr>
-          <p:cNvPr id="18" name="Rectangle 17"/>
+          <p:cNvPr id="17" name="Rectangle 16"/>
           <p:cNvSpPr/>
           <p:nvPr/>
         </p:nvSpPr>
@@ -9688,7 +9678,7 @@
       </p:sp>
       <p:sp>
         <p:nvSpPr>
-          <p:cNvPr id="19" name="TextBox 18"/>
+          <p:cNvPr id="18" name="TextBox 17"/>
           <p:cNvSpPr txBox="1"/>
           <p:nvPr/>
         </p:nvSpPr>
@@ -9747,7 +9737,7 @@
       </p:sp>
       <p:sp>
         <p:nvSpPr>
-          <p:cNvPr id="20" name="Rounded Rectangle 19"/>
+          <p:cNvPr id="19" name="Rounded Rectangle 18"/>
           <p:cNvSpPr/>
           <p:nvPr/>
         </p:nvSpPr>
@@ -9792,7 +9782,7 @@
       </p:sp>
       <p:sp>
         <p:nvSpPr>
-          <p:cNvPr id="21" name="Rectangle 20"/>
+          <p:cNvPr id="20" name="Rectangle 19"/>
           <p:cNvSpPr/>
           <p:nvPr/>
         </p:nvSpPr>
@@ -9835,7 +9825,7 @@
       </p:sp>
       <p:sp>
         <p:nvSpPr>
-          <p:cNvPr id="22" name="TextBox 21"/>
+          <p:cNvPr id="21" name="TextBox 20"/>
           <p:cNvSpPr txBox="1"/>
           <p:nvPr/>
         </p:nvSpPr>
@@ -15880,7 +15870,7 @@
       </p:sp>
       <p:pic>
         <p:nvPicPr>
-          <p:cNvPr id="6" name="Picture 5" descr="web-django.jpg"/>
+          <p:cNvPr id="6" name="Picture 5" descr="panel-web.jpg"/>
           <p:cNvPicPr>
             <a:picLocks noChangeAspect="1"/>
           </p:cNvPicPr>
@@ -15902,33 +15892,9 @@
           </a:prstGeom>
         </p:spPr>
       </p:pic>
-      <p:pic>
-        <p:nvPicPr>
-          <p:cNvPr id="7" name="Picture 6" descr="overlay-soft.png"/>
-          <p:cNvPicPr>
-            <a:picLocks noChangeAspect="1"/>
-          </p:cNvPicPr>
-          <p:nvPr/>
-        </p:nvPicPr>
-        <p:blipFill>
-          <a:blip r:embed="rId3"/>
-          <a:stretch>
-            <a:fillRect/>
-          </a:stretch>
-        </p:blipFill>
-        <p:spPr>
-          <a:xfrm>
-            <a:off x="7635240" y="0"/>
-            <a:ext cx="4572000" cy="6858000"/>
-          </a:xfrm>
-          <a:prstGeom prst="rect">
-            <a:avLst/>
-          </a:prstGeom>
-        </p:spPr>
-      </p:pic>
-      <p:sp>
-        <p:nvSpPr>
-          <p:cNvPr id="8" name="TextBox 7"/>
+      <p:sp>
+        <p:nvSpPr>
+          <p:cNvPr id="7" name="TextBox 6"/>
           <p:cNvSpPr txBox="1"/>
           <p:nvPr/>
         </p:nvSpPr>
@@ -15987,7 +15953,7 @@
       </p:sp>
       <p:sp>
         <p:nvSpPr>
-          <p:cNvPr id="9" name="Rounded Rectangle 8"/>
+          <p:cNvPr id="8" name="Rounded Rectangle 7"/>
           <p:cNvSpPr/>
           <p:nvPr/>
         </p:nvSpPr>
@@ -16032,7 +15998,7 @@
       </p:sp>
       <p:sp>
         <p:nvSpPr>
-          <p:cNvPr id="10" name="TextBox 9"/>
+          <p:cNvPr id="9" name="TextBox 8"/>
           <p:cNvSpPr txBox="1"/>
           <p:nvPr/>
         </p:nvSpPr>

</xml_diff>